<commit_message>
Add architecture diagram to PPTX slide 5 and HTML poster
- build_pptx.py: slide 5 is now a full-width boxes-and-arrows flow diagram
  (Ticket -> Streamlit -> AI Agent -> Risk Engine/MCP Tools/Response+Audit
  -> data + fake env) with a security-gate caption
- sunum_poster.html: theme-aware inline SVG architecture diagram section
- screenshots/: rendered light + dark diagram PNGs

Co-Authored-By: Claude Opus 4.8 <noreply@anthropic.com>
Claude-Session: https://claude.ai/code/session_01SbBaAo5CkEQBtfaSjrUU51
</commit_message>
<xml_diff>
--- a/ai_helpdesk_agent_demo_sunum.pptx
+++ b/ai_helpdesk_agent_demo_sunum.pptx
@@ -949,7 +949,7 @@
           <a:lstStyle/>
           <a:p>
             <a:r>
-              <a:t>[Sistem Mimarisi]</a:t>
+              <a:t>[Sistem Mimarisi — Akis Diyagrami]</a:t>
             </a:r>
           </a:p>
           <a:p/>
@@ -960,7 +960,7 @@
           </a:p>
           <a:p>
             <a:r>
-              <a:t>Mimari modulerdir; her katmanin tek sorumlulugu var. En onemli detay: AI ne siniflandirirsa siniflandirsin, risk karari her zaman bagimsiz Risk Engine tarafindan yeniden dogrulanir.</a:t>
+              <a:t>Mimari modulerdir; her katmanin tek sorumlulugu var. En onemli detay: AI ne siniflandirirsa siniflandirsin, risk karari her zaman bagimsiz Risk Engine tarafindan yeniden dogrulanir. Bu diyagram, isteklerin nasil katman katman guvenlik kapilarindan gectigini gosterir.</a:t>
             </a:r>
           </a:p>
           <a:p/>
@@ -7952,190 +7952,27 @@
                 </a:solidFill>
                 <a:latin typeface="Calibri"/>
               </a:rPr>
-              <a:t>Sistem Mimarisi</a:t>
-            </a:r>
-          </a:p>
-        </p:txBody>
-      </p:sp>
-      <p:sp>
-        <p:nvSpPr>
-          <p:cNvPr id="8" name="TextBox 7"/>
-          <p:cNvSpPr txBox="1"/>
-          <p:nvPr/>
-        </p:nvSpPr>
-        <p:spPr>
-          <a:xfrm>
-            <a:off x="640080" y="1691640"/>
-            <a:ext cx="6766560" cy="3566160"/>
-          </a:xfrm>
-          <a:prstGeom prst="rect">
-            <a:avLst/>
-          </a:prstGeom>
-          <a:noFill/>
-        </p:spPr>
-        <p:txBody>
-          <a:bodyPr wrap="square" anchor="t">
-            <a:spAutoFit/>
-          </a:bodyPr>
-          <a:lstStyle/>
-          <a:p>
-            <a:pPr algn="l">
-              <a:lnSpc>
-                <a:spcPct val="105000"/>
-              </a:lnSpc>
-              <a:spcAft>
-                <a:spcPts val="1000"/>
-              </a:spcAft>
-            </a:pPr>
-            <a:r>
-              <a:rPr sz="1500" b="1">
-                <a:solidFill>
-                  <a:srgbClr val="148F86"/>
-                </a:solidFill>
-                <a:latin typeface="Calibri"/>
-              </a:rPr>
-              <a:t>•  </a:t>
-            </a:r>
-            <a:r>
-              <a:rPr sz="1500" b="0">
-                <a:solidFill>
-                  <a:srgbClr val="1A222E"/>
-                </a:solidFill>
-                <a:latin typeface="Calibri"/>
-              </a:rPr>
-              <a:t>Streamlit UI -&gt; kullanici arayuzu</a:t>
-            </a:r>
-          </a:p>
-          <a:p>
-            <a:pPr algn="l">
-              <a:lnSpc>
-                <a:spcPct val="105000"/>
-              </a:lnSpc>
-              <a:spcAft>
-                <a:spcPts val="1000"/>
-              </a:spcAft>
-            </a:pPr>
-            <a:r>
-              <a:rPr sz="1500" b="1">
-                <a:solidFill>
-                  <a:srgbClr val="148F86"/>
-                </a:solidFill>
-                <a:latin typeface="Calibri"/>
-              </a:rPr>
-              <a:t>•  </a:t>
-            </a:r>
-            <a:r>
-              <a:rPr sz="1500" b="0">
-                <a:solidFill>
-                  <a:srgbClr val="1A222E"/>
-                </a:solidFill>
-                <a:latin typeface="Calibri"/>
-              </a:rPr>
-              <a:t>AI Agent -&gt; Ollama (varsa) veya rule-based fallback</a:t>
-            </a:r>
-          </a:p>
-          <a:p>
-            <a:pPr algn="l">
-              <a:lnSpc>
-                <a:spcPct val="105000"/>
-              </a:lnSpc>
-              <a:spcAft>
-                <a:spcPts val="1000"/>
-              </a:spcAft>
-            </a:pPr>
-            <a:r>
-              <a:rPr sz="1500" b="1">
-                <a:solidFill>
-                  <a:srgbClr val="148F86"/>
-                </a:solidFill>
-                <a:latin typeface="Calibri"/>
-              </a:rPr>
-              <a:t>•  </a:t>
-            </a:r>
-            <a:r>
-              <a:rPr sz="1500" b="0">
-                <a:solidFill>
-                  <a:srgbClr val="1A222E"/>
-                </a:solidFill>
-                <a:latin typeface="Calibri"/>
-              </a:rPr>
-              <a:t>Risk Engine -&gt; Low / Medium / High kararlari</a:t>
-            </a:r>
-          </a:p>
-          <a:p>
-            <a:pPr algn="l">
-              <a:lnSpc>
-                <a:spcPct val="105000"/>
-              </a:lnSpc>
-              <a:spcAft>
-                <a:spcPts val="1000"/>
-              </a:spcAft>
-            </a:pPr>
-            <a:r>
-              <a:rPr sz="1500" b="1">
-                <a:solidFill>
-                  <a:srgbClr val="148F86"/>
-                </a:solidFill>
-                <a:latin typeface="Calibri"/>
-              </a:rPr>
-              <a:t>•  </a:t>
-            </a:r>
-            <a:r>
-              <a:rPr sz="1500" b="0">
-                <a:solidFill>
-                  <a:srgbClr val="1A222E"/>
-                </a:solidFill>
-                <a:latin typeface="Calibri"/>
-              </a:rPr>
-              <a:t>MCP Tools (11 adet) + Response Generator + Audit Logger</a:t>
-            </a:r>
-          </a:p>
-          <a:p>
-            <a:pPr algn="l">
-              <a:lnSpc>
-                <a:spcPct val="105000"/>
-              </a:lnSpc>
-              <a:spcAft>
-                <a:spcPts val="1000"/>
-              </a:spcAft>
-            </a:pPr>
-            <a:r>
-              <a:rPr sz="1500" b="1">
-                <a:solidFill>
-                  <a:srgbClr val="148F86"/>
-                </a:solidFill>
-                <a:latin typeface="Calibri"/>
-              </a:rPr>
-              <a:t>•  </a:t>
-            </a:r>
-            <a:r>
-              <a:rPr sz="1500" b="0">
-                <a:solidFill>
-                  <a:srgbClr val="1A222E"/>
-                </a:solidFill>
-                <a:latin typeface="Calibri"/>
-              </a:rPr>
-              <a:t>Veri: data/*.json + fake ortam: demo_environment/*</a:t>
-            </a:r>
-          </a:p>
-        </p:txBody>
-      </p:sp>
-      <p:sp>
-        <p:nvSpPr>
-          <p:cNvPr id="9" name="Rectangle 8"/>
+              <a:t>Sistem Mimarisi — Akis Diyagrami</a:t>
+            </a:r>
+          </a:p>
+        </p:txBody>
+      </p:sp>
+      <p:sp>
+        <p:nvSpPr>
+          <p:cNvPr id="8" name="Rounded Rectangle 7"/>
           <p:cNvSpPr/>
           <p:nvPr/>
         </p:nvSpPr>
         <p:spPr>
           <a:xfrm>
-            <a:off x="7589520" y="1691640"/>
-            <a:ext cx="4114800" cy="4480560"/>
-          </a:xfrm>
-          <a:prstGeom prst="rect">
+            <a:off x="4572000" y="1572768"/>
+            <a:ext cx="3044952" cy="475488"/>
+          </a:xfrm>
+          <a:prstGeom prst="roundRect">
             <a:avLst/>
           </a:prstGeom>
           <a:solidFill>
-            <a:srgbClr val="FFFFFF"/>
+            <a:srgbClr val="1B2A41"/>
           </a:solidFill>
           <a:ln>
             <a:noFill/>
@@ -8156,6 +7993,58 @@
           </a:fontRef>
         </p:style>
         <p:txBody>
+          <a:bodyPr rtlCol="0" anchor="ctr" wrap="square"/>
+          <a:lstStyle/>
+          <a:p>
+            <a:pPr algn="ctr"/>
+            <a:r>
+              <a:rPr sz="1300" b="1">
+                <a:solidFill>
+                  <a:srgbClr val="FFFFFF"/>
+                </a:solidFill>
+                <a:latin typeface="Calibri"/>
+              </a:rPr>
+              <a:t>Kullanici / Ticket</a:t>
+            </a:r>
+          </a:p>
+        </p:txBody>
+      </p:sp>
+      <p:sp>
+        <p:nvSpPr>
+          <p:cNvPr id="9" name="Down Arrow 8"/>
+          <p:cNvSpPr/>
+          <p:nvPr/>
+        </p:nvSpPr>
+        <p:spPr>
+          <a:xfrm>
+            <a:off x="5989320" y="2066543"/>
+            <a:ext cx="201168" cy="219456"/>
+          </a:xfrm>
+          <a:prstGeom prst="downArrow">
+            <a:avLst/>
+          </a:prstGeom>
+          <a:solidFill>
+            <a:srgbClr val="148F86"/>
+          </a:solidFill>
+          <a:ln>
+            <a:noFill/>
+          </a:ln>
+        </p:spPr>
+        <p:style>
+          <a:lnRef idx="1">
+            <a:schemeClr val="accent1"/>
+          </a:lnRef>
+          <a:fillRef idx="3">
+            <a:schemeClr val="accent1"/>
+          </a:fillRef>
+          <a:effectRef idx="2">
+            <a:schemeClr val="accent1"/>
+          </a:effectRef>
+          <a:fontRef idx="minor">
+            <a:schemeClr val="lt1"/>
+          </a:fontRef>
+        </p:style>
+        <p:txBody>
           <a:bodyPr rtlCol="0" anchor="ctr"/>
           <a:lstStyle/>
           <a:p>
@@ -8165,16 +8054,175 @@
       </p:sp>
       <p:sp>
         <p:nvSpPr>
-          <p:cNvPr id="10" name="Rectangle 9"/>
+          <p:cNvPr id="10" name="Rounded Rectangle 9"/>
           <p:cNvSpPr/>
           <p:nvPr/>
         </p:nvSpPr>
         <p:spPr>
           <a:xfrm>
-            <a:off x="7589520" y="1691640"/>
-            <a:ext cx="4114800" cy="73152"/>
-          </a:xfrm>
-          <a:prstGeom prst="rect">
+            <a:off x="2286000" y="2304288"/>
+            <a:ext cx="7616952" cy="512064"/>
+          </a:xfrm>
+          <a:prstGeom prst="roundRect">
+            <a:avLst/>
+          </a:prstGeom>
+          <a:solidFill>
+            <a:srgbClr val="148F86"/>
+          </a:solidFill>
+          <a:ln>
+            <a:noFill/>
+          </a:ln>
+        </p:spPr>
+        <p:style>
+          <a:lnRef idx="1">
+            <a:schemeClr val="accent1"/>
+          </a:lnRef>
+          <a:fillRef idx="3">
+            <a:schemeClr val="accent1"/>
+          </a:fillRef>
+          <a:effectRef idx="2">
+            <a:schemeClr val="accent1"/>
+          </a:effectRef>
+          <a:fontRef idx="minor">
+            <a:schemeClr val="lt1"/>
+          </a:fontRef>
+        </p:style>
+        <p:txBody>
+          <a:bodyPr rtlCol="0" anchor="ctr" wrap="square"/>
+          <a:lstStyle/>
+          <a:p>
+            <a:pPr algn="ctr"/>
+            <a:r>
+              <a:rPr sz="1400" b="1">
+                <a:solidFill>
+                  <a:srgbClr val="FFFFFF"/>
+                </a:solidFill>
+                <a:latin typeface="Calibri"/>
+              </a:rPr>
+              <a:t>Streamlit UI  (app.py)</a:t>
+            </a:r>
+          </a:p>
+        </p:txBody>
+      </p:sp>
+      <p:sp>
+        <p:nvSpPr>
+          <p:cNvPr id="11" name="Down Arrow 10"/>
+          <p:cNvSpPr/>
+          <p:nvPr/>
+        </p:nvSpPr>
+        <p:spPr>
+          <a:xfrm>
+            <a:off x="5989320" y="2834640"/>
+            <a:ext cx="201168" cy="219456"/>
+          </a:xfrm>
+          <a:prstGeom prst="downArrow">
+            <a:avLst/>
+          </a:prstGeom>
+          <a:solidFill>
+            <a:srgbClr val="148F86"/>
+          </a:solidFill>
+          <a:ln>
+            <a:noFill/>
+          </a:ln>
+        </p:spPr>
+        <p:style>
+          <a:lnRef idx="1">
+            <a:schemeClr val="accent1"/>
+          </a:lnRef>
+          <a:fillRef idx="3">
+            <a:schemeClr val="accent1"/>
+          </a:fillRef>
+          <a:effectRef idx="2">
+            <a:schemeClr val="accent1"/>
+          </a:effectRef>
+          <a:fontRef idx="minor">
+            <a:schemeClr val="lt1"/>
+          </a:fontRef>
+        </p:style>
+        <p:txBody>
+          <a:bodyPr rtlCol="0" anchor="ctr"/>
+          <a:lstStyle/>
+          <a:p>
+            <a:pPr algn="ctr"/>
+          </a:p>
+        </p:txBody>
+      </p:sp>
+      <p:sp>
+        <p:nvSpPr>
+          <p:cNvPr id="12" name="Rounded Rectangle 11"/>
+          <p:cNvSpPr/>
+          <p:nvPr/>
+        </p:nvSpPr>
+        <p:spPr>
+          <a:xfrm>
+            <a:off x="2286000" y="3072384"/>
+            <a:ext cx="7616952" cy="786384"/>
+          </a:xfrm>
+          <a:prstGeom prst="roundRect">
+            <a:avLst/>
+          </a:prstGeom>
+          <a:solidFill>
+            <a:srgbClr val="0F1B2D"/>
+          </a:solidFill>
+          <a:ln>
+            <a:noFill/>
+          </a:ln>
+        </p:spPr>
+        <p:style>
+          <a:lnRef idx="1">
+            <a:schemeClr val="accent1"/>
+          </a:lnRef>
+          <a:fillRef idx="3">
+            <a:schemeClr val="accent1"/>
+          </a:fillRef>
+          <a:effectRef idx="2">
+            <a:schemeClr val="accent1"/>
+          </a:effectRef>
+          <a:fontRef idx="minor">
+            <a:schemeClr val="lt1"/>
+          </a:fontRef>
+        </p:style>
+        <p:txBody>
+          <a:bodyPr rtlCol="0" anchor="ctr" wrap="square"/>
+          <a:lstStyle/>
+          <a:p>
+            <a:pPr algn="ctr"/>
+            <a:r>
+              <a:rPr sz="1500" b="1">
+                <a:solidFill>
+                  <a:srgbClr val="FFFFFF"/>
+                </a:solidFill>
+                <a:latin typeface="Calibri"/>
+              </a:rPr>
+              <a:t>AI Agent  (ai_agent.py)</a:t>
+            </a:r>
+          </a:p>
+          <a:p>
+            <a:pPr algn="ctr"/>
+            <a:r>
+              <a:rPr sz="1200" b="0">
+                <a:solidFill>
+                  <a:srgbClr val="AFC2D6"/>
+                </a:solidFill>
+                <a:latin typeface="Calibri"/>
+              </a:rPr>
+              <a:t>intent + kategori + tool secimi</a:t>
+            </a:r>
+          </a:p>
+        </p:txBody>
+      </p:sp>
+      <p:sp>
+        <p:nvSpPr>
+          <p:cNvPr id="13" name="Rounded Rectangle 12"/>
+          <p:cNvSpPr/>
+          <p:nvPr/>
+        </p:nvSpPr>
+        <p:spPr>
+          <a:xfrm>
+            <a:off x="6446520" y="3200400"/>
+            <a:ext cx="1600200" cy="256032"/>
+          </a:xfrm>
+          <a:prstGeom prst="roundRect">
             <a:avLst/>
           </a:prstGeom>
           <a:solidFill>
@@ -8199,113 +8247,38 @@
           </a:fontRef>
         </p:style>
         <p:txBody>
-          <a:bodyPr rtlCol="0" anchor="ctr"/>
+          <a:bodyPr rtlCol="0" anchor="ctr" wrap="square"/>
           <a:lstStyle/>
           <a:p>
             <a:pPr algn="ctr"/>
-          </a:p>
-        </p:txBody>
-      </p:sp>
-      <p:sp>
-        <p:nvSpPr>
-          <p:cNvPr id="11" name="TextBox 10"/>
-          <p:cNvSpPr txBox="1"/>
-          <p:nvPr/>
-        </p:nvSpPr>
-        <p:spPr>
-          <a:xfrm>
-            <a:off x="7863840" y="1874519"/>
-            <a:ext cx="3566160" cy="365760"/>
-          </a:xfrm>
-          <a:prstGeom prst="rect">
-            <a:avLst/>
-          </a:prstGeom>
-          <a:noFill/>
-        </p:spPr>
-        <p:txBody>
-          <a:bodyPr wrap="square" anchor="t">
-            <a:spAutoFit/>
-          </a:bodyPr>
-          <a:lstStyle/>
-          <a:p>
-            <a:pPr algn="l">
-              <a:lnSpc>
-                <a:spcPct val="100000"/>
-              </a:lnSpc>
-              <a:spcAft>
-                <a:spcPts val="600"/>
-              </a:spcAft>
-            </a:pPr>
-            <a:r>
-              <a:rPr sz="1100" b="1">
-                <a:solidFill>
-                  <a:srgbClr val="148F86"/>
-                </a:solidFill>
-                <a:latin typeface="Calibri"/>
-              </a:rPr>
-              <a:t>KONUSMA NOTU</a:t>
-            </a:r>
-          </a:p>
-        </p:txBody>
-      </p:sp>
-      <p:sp>
-        <p:nvSpPr>
-          <p:cNvPr id="12" name="TextBox 11"/>
-          <p:cNvSpPr txBox="1"/>
-          <p:nvPr/>
-        </p:nvSpPr>
-        <p:spPr>
-          <a:xfrm>
-            <a:off x="7863840" y="2240280"/>
-            <a:ext cx="3566160" cy="2377440"/>
-          </a:xfrm>
-          <a:prstGeom prst="rect">
-            <a:avLst/>
-          </a:prstGeom>
-          <a:noFill/>
-        </p:spPr>
-        <p:txBody>
-          <a:bodyPr wrap="square" anchor="t">
-            <a:spAutoFit/>
-          </a:bodyPr>
-          <a:lstStyle/>
-          <a:p>
-            <a:pPr algn="l">
-              <a:lnSpc>
-                <a:spcPct val="108000"/>
-              </a:lnSpc>
-              <a:spcAft>
-                <a:spcPts val="600"/>
-              </a:spcAft>
-            </a:pPr>
-            <a:r>
-              <a:rPr sz="1200" b="0">
-                <a:solidFill>
-                  <a:srgbClr val="5B6B7E"/>
-                </a:solidFill>
-                <a:latin typeface="Calibri"/>
-              </a:rPr>
-              <a:t>Mimari modulerdir; her katmanin tek sorumlulugu var. En onemli detay: AI ne siniflandirirsa siniflandirsin, risk karari her zaman bagimsiz Risk Engine tarafindan yeniden dogrulanir.</a:t>
-            </a:r>
-          </a:p>
-        </p:txBody>
-      </p:sp>
-      <p:sp>
-        <p:nvSpPr>
-          <p:cNvPr id="13" name="Rectangle 12"/>
+            <a:r>
+              <a:rPr sz="950" b="1">
+                <a:solidFill>
+                  <a:srgbClr val="0F1B2D"/>
+                </a:solidFill>
+                <a:latin typeface="Calibri"/>
+              </a:rPr>
+              <a:t>Ollama (varsa)</a:t>
+            </a:r>
+          </a:p>
+        </p:txBody>
+      </p:sp>
+      <p:sp>
+        <p:nvSpPr>
+          <p:cNvPr id="14" name="Rounded Rectangle 13"/>
           <p:cNvSpPr/>
           <p:nvPr/>
         </p:nvSpPr>
         <p:spPr>
           <a:xfrm>
-            <a:off x="7863840" y="4892040"/>
-            <a:ext cx="3566160" cy="18288"/>
-          </a:xfrm>
-          <a:prstGeom prst="rect">
+            <a:off x="8183879" y="3200400"/>
+            <a:ext cx="1600200" cy="256032"/>
+          </a:xfrm>
+          <a:prstGeom prst="roundRect">
             <a:avLst/>
           </a:prstGeom>
           <a:solidFill>
-            <a:srgbClr val="DDE3EA"/>
+            <a:srgbClr val="C9D6E4"/>
           </a:solidFill>
           <a:ln>
             <a:noFill/>
@@ -8326,6 +8299,58 @@
           </a:fontRef>
         </p:style>
         <p:txBody>
+          <a:bodyPr rtlCol="0" anchor="ctr" wrap="square"/>
+          <a:lstStyle/>
+          <a:p>
+            <a:pPr algn="ctr"/>
+            <a:r>
+              <a:rPr sz="950" b="1">
+                <a:solidFill>
+                  <a:srgbClr val="0F1B2D"/>
+                </a:solidFill>
+                <a:latin typeface="Calibri"/>
+              </a:rPr>
+              <a:t>Rule-based fallback</a:t>
+            </a:r>
+          </a:p>
+        </p:txBody>
+      </p:sp>
+      <p:sp>
+        <p:nvSpPr>
+          <p:cNvPr id="15" name="Down Arrow 14"/>
+          <p:cNvSpPr/>
+          <p:nvPr/>
+        </p:nvSpPr>
+        <p:spPr>
+          <a:xfrm>
+            <a:off x="2231136" y="3877056"/>
+            <a:ext cx="201168" cy="219456"/>
+          </a:xfrm>
+          <a:prstGeom prst="downArrow">
+            <a:avLst/>
+          </a:prstGeom>
+          <a:solidFill>
+            <a:srgbClr val="148F86"/>
+          </a:solidFill>
+          <a:ln>
+            <a:noFill/>
+          </a:ln>
+        </p:spPr>
+        <p:style>
+          <a:lnRef idx="1">
+            <a:schemeClr val="accent1"/>
+          </a:lnRef>
+          <a:fillRef idx="3">
+            <a:schemeClr val="accent1"/>
+          </a:fillRef>
+          <a:effectRef idx="2">
+            <a:schemeClr val="accent1"/>
+          </a:effectRef>
+          <a:fontRef idx="minor">
+            <a:schemeClr val="lt1"/>
+          </a:fontRef>
+        </p:style>
+        <p:txBody>
           <a:bodyPr rtlCol="0" anchor="ctr"/>
           <a:lstStyle/>
           <a:p>
@@ -8335,56 +8360,510 @@
       </p:sp>
       <p:sp>
         <p:nvSpPr>
-          <p:cNvPr id="14" name="TextBox 13"/>
+          <p:cNvPr id="16" name="Down Arrow 15"/>
+          <p:cNvSpPr/>
+          <p:nvPr/>
+        </p:nvSpPr>
+        <p:spPr>
+          <a:xfrm>
+            <a:off x="5989320" y="3877056"/>
+            <a:ext cx="201168" cy="219456"/>
+          </a:xfrm>
+          <a:prstGeom prst="downArrow">
+            <a:avLst/>
+          </a:prstGeom>
+          <a:solidFill>
+            <a:srgbClr val="148F86"/>
+          </a:solidFill>
+          <a:ln>
+            <a:noFill/>
+          </a:ln>
+        </p:spPr>
+        <p:style>
+          <a:lnRef idx="1">
+            <a:schemeClr val="accent1"/>
+          </a:lnRef>
+          <a:fillRef idx="3">
+            <a:schemeClr val="accent1"/>
+          </a:fillRef>
+          <a:effectRef idx="2">
+            <a:schemeClr val="accent1"/>
+          </a:effectRef>
+          <a:fontRef idx="minor">
+            <a:schemeClr val="lt1"/>
+          </a:fontRef>
+        </p:style>
+        <p:txBody>
+          <a:bodyPr rtlCol="0" anchor="ctr"/>
+          <a:lstStyle/>
+          <a:p>
+            <a:pPr algn="ctr"/>
+          </a:p>
+        </p:txBody>
+      </p:sp>
+      <p:sp>
+        <p:nvSpPr>
+          <p:cNvPr id="17" name="Down Arrow 16"/>
+          <p:cNvSpPr/>
+          <p:nvPr/>
+        </p:nvSpPr>
+        <p:spPr>
+          <a:xfrm>
+            <a:off x="9729216" y="3877056"/>
+            <a:ext cx="201168" cy="219456"/>
+          </a:xfrm>
+          <a:prstGeom prst="downArrow">
+            <a:avLst/>
+          </a:prstGeom>
+          <a:solidFill>
+            <a:srgbClr val="148F86"/>
+          </a:solidFill>
+          <a:ln>
+            <a:noFill/>
+          </a:ln>
+        </p:spPr>
+        <p:style>
+          <a:lnRef idx="1">
+            <a:schemeClr val="accent1"/>
+          </a:lnRef>
+          <a:fillRef idx="3">
+            <a:schemeClr val="accent1"/>
+          </a:fillRef>
+          <a:effectRef idx="2">
+            <a:schemeClr val="accent1"/>
+          </a:effectRef>
+          <a:fontRef idx="minor">
+            <a:schemeClr val="lt1"/>
+          </a:fontRef>
+        </p:style>
+        <p:txBody>
+          <a:bodyPr rtlCol="0" anchor="ctr"/>
+          <a:lstStyle/>
+          <a:p>
+            <a:pPr algn="ctr"/>
+          </a:p>
+        </p:txBody>
+      </p:sp>
+      <p:sp>
+        <p:nvSpPr>
+          <p:cNvPr id="18" name="Rounded Rectangle 17"/>
+          <p:cNvSpPr/>
+          <p:nvPr/>
+        </p:nvSpPr>
+        <p:spPr>
+          <a:xfrm>
+            <a:off x="640080" y="4114800"/>
+            <a:ext cx="3383280" cy="914400"/>
+          </a:xfrm>
+          <a:prstGeom prst="roundRect">
+            <a:avLst/>
+          </a:prstGeom>
+          <a:solidFill>
+            <a:srgbClr val="1B2A41"/>
+          </a:solidFill>
+          <a:ln w="19050">
+            <a:solidFill>
+              <a:srgbClr val="DC2626"/>
+            </a:solidFill>
+          </a:ln>
+        </p:spPr>
+        <p:style>
+          <a:lnRef idx="1">
+            <a:schemeClr val="accent1"/>
+          </a:lnRef>
+          <a:fillRef idx="3">
+            <a:schemeClr val="accent1"/>
+          </a:fillRef>
+          <a:effectRef idx="2">
+            <a:schemeClr val="accent1"/>
+          </a:effectRef>
+          <a:fontRef idx="minor">
+            <a:schemeClr val="lt1"/>
+          </a:fontRef>
+        </p:style>
+        <p:txBody>
+          <a:bodyPr rtlCol="0" anchor="ctr" wrap="square"/>
+          <a:lstStyle/>
+          <a:p>
+            <a:pPr algn="ctr"/>
+            <a:r>
+              <a:rPr sz="1300" b="1">
+                <a:solidFill>
+                  <a:srgbClr val="FFFFFF"/>
+                </a:solidFill>
+                <a:latin typeface="Calibri"/>
+              </a:rPr>
+              <a:t>Risk Engine</a:t>
+            </a:r>
+          </a:p>
+          <a:p>
+            <a:pPr algn="ctr"/>
+            <a:r>
+              <a:rPr sz="1000" b="0">
+                <a:solidFill>
+                  <a:srgbClr val="F2C9C9"/>
+                </a:solidFill>
+                <a:latin typeface="Calibri"/>
+              </a:rPr>
+              <a:t>Low / Medium / High  ·  High=blocked, Medium=onay</a:t>
+            </a:r>
+          </a:p>
+        </p:txBody>
+      </p:sp>
+      <p:sp>
+        <p:nvSpPr>
+          <p:cNvPr id="19" name="Rounded Rectangle 18"/>
+          <p:cNvSpPr/>
+          <p:nvPr/>
+        </p:nvSpPr>
+        <p:spPr>
+          <a:xfrm>
+            <a:off x="4398264" y="4114800"/>
+            <a:ext cx="3383280" cy="914400"/>
+          </a:xfrm>
+          <a:prstGeom prst="roundRect">
+            <a:avLst/>
+          </a:prstGeom>
+          <a:solidFill>
+            <a:srgbClr val="1B2A41"/>
+          </a:solidFill>
+          <a:ln w="19050">
+            <a:solidFill>
+              <a:srgbClr val="2DD4BF"/>
+            </a:solidFill>
+          </a:ln>
+        </p:spPr>
+        <p:style>
+          <a:lnRef idx="1">
+            <a:schemeClr val="accent1"/>
+          </a:lnRef>
+          <a:fillRef idx="3">
+            <a:schemeClr val="accent1"/>
+          </a:fillRef>
+          <a:effectRef idx="2">
+            <a:schemeClr val="accent1"/>
+          </a:effectRef>
+          <a:fontRef idx="minor">
+            <a:schemeClr val="lt1"/>
+          </a:fontRef>
+        </p:style>
+        <p:txBody>
+          <a:bodyPr rtlCol="0" anchor="ctr" wrap="square"/>
+          <a:lstStyle/>
+          <a:p>
+            <a:pPr algn="ctr"/>
+            <a:r>
+              <a:rPr sz="1300" b="1">
+                <a:solidFill>
+                  <a:srgbClr val="FFFFFF"/>
+                </a:solidFill>
+                <a:latin typeface="Calibri"/>
+              </a:rPr>
+              <a:t>MCP Tools  (11 simule)</a:t>
+            </a:r>
+          </a:p>
+          <a:p>
+            <a:pPr algn="ctr"/>
+            <a:r>
+              <a:rPr sz="1000" b="0">
+                <a:solidFill>
+                  <a:srgbClr val="B9EEE7"/>
+                </a:solidFill>
+                <a:latin typeface="Calibri"/>
+              </a:rPr>
+              <a:t>AI yalnizca tanimli tool'lari cagirir</a:t>
+            </a:r>
+          </a:p>
+        </p:txBody>
+      </p:sp>
+      <p:sp>
+        <p:nvSpPr>
+          <p:cNvPr id="20" name="Rounded Rectangle 19"/>
+          <p:cNvSpPr/>
+          <p:nvPr/>
+        </p:nvSpPr>
+        <p:spPr>
+          <a:xfrm>
+            <a:off x="8156448" y="4114800"/>
+            <a:ext cx="3383280" cy="914400"/>
+          </a:xfrm>
+          <a:prstGeom prst="roundRect">
+            <a:avLst/>
+          </a:prstGeom>
+          <a:solidFill>
+            <a:srgbClr val="1B2A41"/>
+          </a:solidFill>
+          <a:ln>
+            <a:noFill/>
+          </a:ln>
+        </p:spPr>
+        <p:style>
+          <a:lnRef idx="1">
+            <a:schemeClr val="accent1"/>
+          </a:lnRef>
+          <a:fillRef idx="3">
+            <a:schemeClr val="accent1"/>
+          </a:fillRef>
+          <a:effectRef idx="2">
+            <a:schemeClr val="accent1"/>
+          </a:effectRef>
+          <a:fontRef idx="minor">
+            <a:schemeClr val="lt1"/>
+          </a:fontRef>
+        </p:style>
+        <p:txBody>
+          <a:bodyPr rtlCol="0" anchor="ctr" wrap="square"/>
+          <a:lstStyle/>
+          <a:p>
+            <a:pPr algn="ctr"/>
+            <a:r>
+              <a:rPr sz="1250" b="1">
+                <a:solidFill>
+                  <a:srgbClr val="FFFFFF"/>
+                </a:solidFill>
+                <a:latin typeface="Calibri"/>
+              </a:rPr>
+              <a:t>Response Gen + Audit Logger</a:t>
+            </a:r>
+          </a:p>
+          <a:p>
+            <a:pPr algn="ctr"/>
+            <a:r>
+              <a:rPr sz="950" b="0">
+                <a:solidFill>
+                  <a:srgbClr val="AFC2D6"/>
+                </a:solidFill>
+                <a:latin typeface="Calibri"/>
+              </a:rPr>
+              <a:t>Turkce cevap + JSONL log</a:t>
+            </a:r>
+          </a:p>
+        </p:txBody>
+      </p:sp>
+      <p:sp>
+        <p:nvSpPr>
+          <p:cNvPr id="21" name="Down Arrow 20"/>
+          <p:cNvSpPr/>
+          <p:nvPr/>
+        </p:nvSpPr>
+        <p:spPr>
+          <a:xfrm>
+            <a:off x="3374136" y="5065776"/>
+            <a:ext cx="201168" cy="201168"/>
+          </a:xfrm>
+          <a:prstGeom prst="downArrow">
+            <a:avLst/>
+          </a:prstGeom>
+          <a:solidFill>
+            <a:srgbClr val="148F86"/>
+          </a:solidFill>
+          <a:ln>
+            <a:noFill/>
+          </a:ln>
+        </p:spPr>
+        <p:style>
+          <a:lnRef idx="1">
+            <a:schemeClr val="accent1"/>
+          </a:lnRef>
+          <a:fillRef idx="3">
+            <a:schemeClr val="accent1"/>
+          </a:fillRef>
+          <a:effectRef idx="2">
+            <a:schemeClr val="accent1"/>
+          </a:effectRef>
+          <a:fontRef idx="minor">
+            <a:schemeClr val="lt1"/>
+          </a:fontRef>
+        </p:style>
+        <p:txBody>
+          <a:bodyPr rtlCol="0" anchor="ctr"/>
+          <a:lstStyle/>
+          <a:p>
+            <a:pPr algn="ctr"/>
+          </a:p>
+        </p:txBody>
+      </p:sp>
+      <p:sp>
+        <p:nvSpPr>
+          <p:cNvPr id="22" name="Down Arrow 21"/>
+          <p:cNvSpPr/>
+          <p:nvPr/>
+        </p:nvSpPr>
+        <p:spPr>
+          <a:xfrm>
+            <a:off x="8586216" y="5065776"/>
+            <a:ext cx="201168" cy="201168"/>
+          </a:xfrm>
+          <a:prstGeom prst="downArrow">
+            <a:avLst/>
+          </a:prstGeom>
+          <a:solidFill>
+            <a:srgbClr val="148F86"/>
+          </a:solidFill>
+          <a:ln>
+            <a:noFill/>
+          </a:ln>
+        </p:spPr>
+        <p:style>
+          <a:lnRef idx="1">
+            <a:schemeClr val="accent1"/>
+          </a:lnRef>
+          <a:fillRef idx="3">
+            <a:schemeClr val="accent1"/>
+          </a:fillRef>
+          <a:effectRef idx="2">
+            <a:schemeClr val="accent1"/>
+          </a:effectRef>
+          <a:fontRef idx="minor">
+            <a:schemeClr val="lt1"/>
+          </a:fontRef>
+        </p:style>
+        <p:txBody>
+          <a:bodyPr rtlCol="0" anchor="ctr"/>
+          <a:lstStyle/>
+          <a:p>
+            <a:pPr algn="ctr"/>
+          </a:p>
+        </p:txBody>
+      </p:sp>
+      <p:sp>
+        <p:nvSpPr>
+          <p:cNvPr id="23" name="Rounded Rectangle 22"/>
+          <p:cNvSpPr/>
+          <p:nvPr/>
+        </p:nvSpPr>
+        <p:spPr>
+          <a:xfrm>
+            <a:off x="1188720" y="5285232"/>
+            <a:ext cx="4572000" cy="566928"/>
+          </a:xfrm>
+          <a:prstGeom prst="roundRect">
+            <a:avLst/>
+          </a:prstGeom>
+          <a:solidFill>
+            <a:srgbClr val="148F86"/>
+          </a:solidFill>
+          <a:ln>
+            <a:noFill/>
+          </a:ln>
+        </p:spPr>
+        <p:style>
+          <a:lnRef idx="1">
+            <a:schemeClr val="accent1"/>
+          </a:lnRef>
+          <a:fillRef idx="3">
+            <a:schemeClr val="accent1"/>
+          </a:fillRef>
+          <a:effectRef idx="2">
+            <a:schemeClr val="accent1"/>
+          </a:effectRef>
+          <a:fontRef idx="minor">
+            <a:schemeClr val="lt1"/>
+          </a:fontRef>
+        </p:style>
+        <p:txBody>
+          <a:bodyPr rtlCol="0" anchor="ctr" wrap="square"/>
+          <a:lstStyle/>
+          <a:p>
+            <a:pPr algn="ctr"/>
+            <a:r>
+              <a:rPr sz="1250" b="1">
+                <a:solidFill>
+                  <a:srgbClr val="FFFFFF"/>
+                </a:solidFill>
+                <a:latin typeface="Calibri"/>
+              </a:rPr>
+              <a:t>data/*.json</a:t>
+            </a:r>
+          </a:p>
+          <a:p>
+            <a:pPr algn="ctr"/>
+            <a:r>
+              <a:rPr sz="950" b="0">
+                <a:solidFill>
+                  <a:srgbClr val="EAF6F4"/>
+                </a:solidFill>
+                <a:latin typeface="Calibri"/>
+              </a:rPr>
+              <a:t>ticket · user · printer · ERP · software · KB</a:t>
+            </a:r>
+          </a:p>
+        </p:txBody>
+      </p:sp>
+      <p:sp>
+        <p:nvSpPr>
+          <p:cNvPr id="24" name="Rounded Rectangle 23"/>
+          <p:cNvSpPr/>
+          <p:nvPr/>
+        </p:nvSpPr>
+        <p:spPr>
+          <a:xfrm>
+            <a:off x="6400800" y="5285232"/>
+            <a:ext cx="4572000" cy="566928"/>
+          </a:xfrm>
+          <a:prstGeom prst="roundRect">
+            <a:avLst/>
+          </a:prstGeom>
+          <a:solidFill>
+            <a:srgbClr val="148F86"/>
+          </a:solidFill>
+          <a:ln>
+            <a:noFill/>
+          </a:ln>
+        </p:spPr>
+        <p:style>
+          <a:lnRef idx="1">
+            <a:schemeClr val="accent1"/>
+          </a:lnRef>
+          <a:fillRef idx="3">
+            <a:schemeClr val="accent1"/>
+          </a:fillRef>
+          <a:effectRef idx="2">
+            <a:schemeClr val="accent1"/>
+          </a:effectRef>
+          <a:fontRef idx="minor">
+            <a:schemeClr val="lt1"/>
+          </a:fontRef>
+        </p:style>
+        <p:txBody>
+          <a:bodyPr rtlCol="0" anchor="ctr" wrap="square"/>
+          <a:lstStyle/>
+          <a:p>
+            <a:pPr algn="ctr"/>
+            <a:r>
+              <a:rPr sz="1250" b="1">
+                <a:solidFill>
+                  <a:srgbClr val="FFFFFF"/>
+                </a:solidFill>
+                <a:latin typeface="Calibri"/>
+              </a:rPr>
+              <a:t>demo_environment/*  (fake)</a:t>
+            </a:r>
+          </a:p>
+          <a:p>
+            <a:pPr algn="ctr"/>
+            <a:r>
+              <a:rPr sz="950" b="0">
+                <a:solidFill>
+                  <a:srgbClr val="EAF6F4"/>
+                </a:solidFill>
+                <a:latin typeface="Calibri"/>
+              </a:rPr>
+              <a:t>fake mailbox · desktop · logs</a:t>
+            </a:r>
+          </a:p>
+        </p:txBody>
+      </p:sp>
+      <p:sp>
+        <p:nvSpPr>
+          <p:cNvPr id="25" name="TextBox 24"/>
           <p:cNvSpPr txBox="1"/>
           <p:nvPr/>
         </p:nvSpPr>
         <p:spPr>
           <a:xfrm>
-            <a:off x="7863840" y="5029200"/>
-            <a:ext cx="3566160" cy="365760"/>
-          </a:xfrm>
-          <a:prstGeom prst="rect">
-            <a:avLst/>
-          </a:prstGeom>
-          <a:noFill/>
-        </p:spPr>
-        <p:txBody>
-          <a:bodyPr wrap="square" anchor="t">
-            <a:spAutoFit/>
-          </a:bodyPr>
-          <a:lstStyle/>
-          <a:p>
-            <a:pPr algn="l">
-              <a:lnSpc>
-                <a:spcPct val="100000"/>
-              </a:lnSpc>
-              <a:spcAft>
-                <a:spcPts val="600"/>
-              </a:spcAft>
-            </a:pPr>
-            <a:r>
-              <a:rPr sz="1100" b="1">
-                <a:solidFill>
-                  <a:srgbClr val="148F86"/>
-                </a:solidFill>
-                <a:latin typeface="Calibri"/>
-              </a:rPr>
-              <a:t>DEMO EKRANI</a:t>
-            </a:r>
-          </a:p>
-        </p:txBody>
-      </p:sp>
-      <p:sp>
-        <p:nvSpPr>
-          <p:cNvPr id="15" name="TextBox 14"/>
-          <p:cNvSpPr txBox="1"/>
-          <p:nvPr/>
-        </p:nvSpPr>
-        <p:spPr>
-          <a:xfrm>
-            <a:off x="7863840" y="5394960"/>
-            <a:ext cx="3566160" cy="731520"/>
+            <a:off x="640080" y="6053328"/>
+            <a:ext cx="10881360" cy="640080"/>
           </a:xfrm>
           <a:prstGeom prst="rect">
             <a:avLst/>
@@ -8406,13 +8885,22 @@
               </a:spcAft>
             </a:pPr>
             <a:r>
-              <a:rPr sz="1150" b="0">
-                <a:solidFill>
-                  <a:srgbClr val="1A222E"/>
-                </a:solidFill>
-                <a:latin typeface="Calibri"/>
-              </a:rPr>
-              <a:t>AI Analysis bolumunu tam goster: Category, Intent, Risk Level, Confidence, Reasoning Summary.</a:t>
+              <a:rPr sz="1100" b="1">
+                <a:solidFill>
+                  <a:srgbClr val="148F86"/>
+                </a:solidFill>
+                <a:latin typeface="Calibri"/>
+              </a:rPr>
+              <a:t>Guvenlik kapisi: </a:t>
+            </a:r>
+            <a:r>
+              <a:rPr sz="1100" b="0">
+                <a:solidFill>
+                  <a:srgbClr val="5B6B7E"/>
+                </a:solidFill>
+                <a:latin typeface="Calibri"/>
+              </a:rPr>
+              <a:t>AI dogrudan sistemlere erisemez; her istek Risk Engine'den gecer, yalnizca guvenli tool'lar calisir ve her islem loglanir.</a:t>
             </a:r>
           </a:p>
         </p:txBody>

</xml_diff>